<commit_message>
Cyber3 - Unit 3 ppt update
</commit_message>
<xml_diff>
--- a/src/site/pdfs/cs3_u3_s2_assessment_workbook.pptx
+++ b/src/site/pdfs/cs3_u3_s2_assessment_workbook.pptx
@@ -266,7 +266,7 @@
           <a:p>
             <a:fld id="{20F5936E-8338-4FF0-A335-701F0F342296}" type="datetimeFigureOut">
               <a:rPr lang="en-GB" smtClean="0"/>
-              <a:t>07/04/2022</a:t>
+              <a:t>10/05/2022</a:t>
             </a:fld>
             <a:endParaRPr lang="en-GB"/>
           </a:p>
@@ -466,7 +466,7 @@
           <a:p>
             <a:fld id="{20F5936E-8338-4FF0-A335-701F0F342296}" type="datetimeFigureOut">
               <a:rPr lang="en-GB" smtClean="0"/>
-              <a:t>07/04/2022</a:t>
+              <a:t>10/05/2022</a:t>
             </a:fld>
             <a:endParaRPr lang="en-GB"/>
           </a:p>
@@ -676,7 +676,7 @@
           <a:p>
             <a:fld id="{20F5936E-8338-4FF0-A335-701F0F342296}" type="datetimeFigureOut">
               <a:rPr lang="en-GB" smtClean="0"/>
-              <a:t>07/04/2022</a:t>
+              <a:t>10/05/2022</a:t>
             </a:fld>
             <a:endParaRPr lang="en-GB"/>
           </a:p>
@@ -1096,7 +1096,7 @@
           <a:p>
             <a:fld id="{20F5936E-8338-4FF0-A335-701F0F342296}" type="datetimeFigureOut">
               <a:rPr lang="en-GB" smtClean="0"/>
-              <a:t>07/04/2022</a:t>
+              <a:t>10/05/2022</a:t>
             </a:fld>
             <a:endParaRPr lang="en-GB"/>
           </a:p>
@@ -1372,7 +1372,7 @@
           <a:p>
             <a:fld id="{20F5936E-8338-4FF0-A335-701F0F342296}" type="datetimeFigureOut">
               <a:rPr lang="en-GB" smtClean="0"/>
-              <a:t>07/04/2022</a:t>
+              <a:t>10/05/2022</a:t>
             </a:fld>
             <a:endParaRPr lang="en-GB"/>
           </a:p>
@@ -1640,7 +1640,7 @@
           <a:p>
             <a:fld id="{20F5936E-8338-4FF0-A335-701F0F342296}" type="datetimeFigureOut">
               <a:rPr lang="en-GB" smtClean="0"/>
-              <a:t>07/04/2022</a:t>
+              <a:t>10/05/2022</a:t>
             </a:fld>
             <a:endParaRPr lang="en-GB"/>
           </a:p>
@@ -2055,7 +2055,7 @@
           <a:p>
             <a:fld id="{20F5936E-8338-4FF0-A335-701F0F342296}" type="datetimeFigureOut">
               <a:rPr lang="en-GB" smtClean="0"/>
-              <a:t>07/04/2022</a:t>
+              <a:t>10/05/2022</a:t>
             </a:fld>
             <a:endParaRPr lang="en-GB"/>
           </a:p>
@@ -2197,7 +2197,7 @@
           <a:p>
             <a:fld id="{20F5936E-8338-4FF0-A335-701F0F342296}" type="datetimeFigureOut">
               <a:rPr lang="en-GB" smtClean="0"/>
-              <a:t>07/04/2022</a:t>
+              <a:t>10/05/2022</a:t>
             </a:fld>
             <a:endParaRPr lang="en-GB"/>
           </a:p>
@@ -2310,7 +2310,7 @@
           <a:p>
             <a:fld id="{20F5936E-8338-4FF0-A335-701F0F342296}" type="datetimeFigureOut">
               <a:rPr lang="en-GB" smtClean="0"/>
-              <a:t>07/04/2022</a:t>
+              <a:t>10/05/2022</a:t>
             </a:fld>
             <a:endParaRPr lang="en-GB"/>
           </a:p>
@@ -2623,7 +2623,7 @@
           <a:p>
             <a:fld id="{20F5936E-8338-4FF0-A335-701F0F342296}" type="datetimeFigureOut">
               <a:rPr lang="en-GB" smtClean="0"/>
-              <a:t>07/04/2022</a:t>
+              <a:t>10/05/2022</a:t>
             </a:fld>
             <a:endParaRPr lang="en-GB"/>
           </a:p>
@@ -2912,7 +2912,7 @@
           <a:p>
             <a:fld id="{20F5936E-8338-4FF0-A335-701F0F342296}" type="datetimeFigureOut">
               <a:rPr lang="en-GB" smtClean="0"/>
-              <a:t>07/04/2022</a:t>
+              <a:t>10/05/2022</a:t>
             </a:fld>
             <a:endParaRPr lang="en-GB"/>
           </a:p>
@@ -3155,7 +3155,7 @@
           <a:p>
             <a:fld id="{20F5936E-8338-4FF0-A335-701F0F342296}" type="datetimeFigureOut">
               <a:rPr lang="en-GB" smtClean="0"/>
-              <a:t>07/04/2022</a:t>
+              <a:t>10/05/2022</a:t>
             </a:fld>
             <a:endParaRPr lang="en-GB"/>
           </a:p>
@@ -4504,7 +4504,7 @@
             </a:br>
             <a:r>
               <a:rPr lang="en-GB" sz="2000" dirty="0"/>
-              <a:t>(for instructions on completing a flow chart, refer to the demonstration video within the course content. By clicking on insert, shapes and flowchart on the tabs above you will find the symbols that you need)</a:t>
+              <a:t>(for instructions on completing a flow chart, refer to the webinar at the end of session 2 within the course content. By clicking on insert, shapes and flowchart on the tabs above you will find the symbols that you need)</a:t>
             </a:r>
           </a:p>
         </p:txBody>

</xml_diff>

<commit_message>
Cyber3 - additional review items
</commit_message>
<xml_diff>
--- a/src/site/pdfs/cs3_u3_s2_assessment_workbook.pptx
+++ b/src/site/pdfs/cs3_u3_s2_assessment_workbook.pptx
@@ -266,7 +266,7 @@
           <a:p>
             <a:fld id="{20F5936E-8338-4FF0-A335-701F0F342296}" type="datetimeFigureOut">
               <a:rPr lang="en-GB" smtClean="0"/>
-              <a:t>10/05/2022</a:t>
+              <a:t>12/05/2022</a:t>
             </a:fld>
             <a:endParaRPr lang="en-GB"/>
           </a:p>
@@ -466,7 +466,7 @@
           <a:p>
             <a:fld id="{20F5936E-8338-4FF0-A335-701F0F342296}" type="datetimeFigureOut">
               <a:rPr lang="en-GB" smtClean="0"/>
-              <a:t>10/05/2022</a:t>
+              <a:t>12/05/2022</a:t>
             </a:fld>
             <a:endParaRPr lang="en-GB"/>
           </a:p>
@@ -676,7 +676,7 @@
           <a:p>
             <a:fld id="{20F5936E-8338-4FF0-A335-701F0F342296}" type="datetimeFigureOut">
               <a:rPr lang="en-GB" smtClean="0"/>
-              <a:t>10/05/2022</a:t>
+              <a:t>12/05/2022</a:t>
             </a:fld>
             <a:endParaRPr lang="en-GB"/>
           </a:p>
@@ -1096,7 +1096,7 @@
           <a:p>
             <a:fld id="{20F5936E-8338-4FF0-A335-701F0F342296}" type="datetimeFigureOut">
               <a:rPr lang="en-GB" smtClean="0"/>
-              <a:t>10/05/2022</a:t>
+              <a:t>12/05/2022</a:t>
             </a:fld>
             <a:endParaRPr lang="en-GB"/>
           </a:p>
@@ -1372,7 +1372,7 @@
           <a:p>
             <a:fld id="{20F5936E-8338-4FF0-A335-701F0F342296}" type="datetimeFigureOut">
               <a:rPr lang="en-GB" smtClean="0"/>
-              <a:t>10/05/2022</a:t>
+              <a:t>12/05/2022</a:t>
             </a:fld>
             <a:endParaRPr lang="en-GB"/>
           </a:p>
@@ -1640,7 +1640,7 @@
           <a:p>
             <a:fld id="{20F5936E-8338-4FF0-A335-701F0F342296}" type="datetimeFigureOut">
               <a:rPr lang="en-GB" smtClean="0"/>
-              <a:t>10/05/2022</a:t>
+              <a:t>12/05/2022</a:t>
             </a:fld>
             <a:endParaRPr lang="en-GB"/>
           </a:p>
@@ -2055,7 +2055,7 @@
           <a:p>
             <a:fld id="{20F5936E-8338-4FF0-A335-701F0F342296}" type="datetimeFigureOut">
               <a:rPr lang="en-GB" smtClean="0"/>
-              <a:t>10/05/2022</a:t>
+              <a:t>12/05/2022</a:t>
             </a:fld>
             <a:endParaRPr lang="en-GB"/>
           </a:p>
@@ -2197,7 +2197,7 @@
           <a:p>
             <a:fld id="{20F5936E-8338-4FF0-A335-701F0F342296}" type="datetimeFigureOut">
               <a:rPr lang="en-GB" smtClean="0"/>
-              <a:t>10/05/2022</a:t>
+              <a:t>12/05/2022</a:t>
             </a:fld>
             <a:endParaRPr lang="en-GB"/>
           </a:p>
@@ -2310,7 +2310,7 @@
           <a:p>
             <a:fld id="{20F5936E-8338-4FF0-A335-701F0F342296}" type="datetimeFigureOut">
               <a:rPr lang="en-GB" smtClean="0"/>
-              <a:t>10/05/2022</a:t>
+              <a:t>12/05/2022</a:t>
             </a:fld>
             <a:endParaRPr lang="en-GB"/>
           </a:p>
@@ -2623,7 +2623,7 @@
           <a:p>
             <a:fld id="{20F5936E-8338-4FF0-A335-701F0F342296}" type="datetimeFigureOut">
               <a:rPr lang="en-GB" smtClean="0"/>
-              <a:t>10/05/2022</a:t>
+              <a:t>12/05/2022</a:t>
             </a:fld>
             <a:endParaRPr lang="en-GB"/>
           </a:p>
@@ -2912,7 +2912,7 @@
           <a:p>
             <a:fld id="{20F5936E-8338-4FF0-A335-701F0F342296}" type="datetimeFigureOut">
               <a:rPr lang="en-GB" smtClean="0"/>
-              <a:t>10/05/2022</a:t>
+              <a:t>12/05/2022</a:t>
             </a:fld>
             <a:endParaRPr lang="en-GB"/>
           </a:p>
@@ -3155,7 +3155,7 @@
           <a:p>
             <a:fld id="{20F5936E-8338-4FF0-A335-701F0F342296}" type="datetimeFigureOut">
               <a:rPr lang="en-GB" smtClean="0"/>
-              <a:t>10/05/2022</a:t>
+              <a:t>12/05/2022</a:t>
             </a:fld>
             <a:endParaRPr lang="en-GB"/>
           </a:p>
@@ -4666,7 +4666,7 @@
           <a:p>
             <a:r>
               <a:rPr lang="en-GB" sz="2000" b="1" dirty="0"/>
-              <a:t>c) Use this slide to develop an appropriate communication to mitigate future vulnerabilities. These may be to staff, pupils or both and can be any format that you choose. </a:t>
+              <a:t>c) Use this slide to develop an appropriate communication to mitigate future vulnerabilities. This may be to staff, pupils or both and can be any format that you choose e.g. email, leaflet or report.  </a:t>
             </a:r>
           </a:p>
         </p:txBody>
@@ -4848,8 +4848,15 @@
           </a:lstStyle>
           <a:p>
             <a:pPr algn="ctr"/>
-            <a:r>
-              <a:rPr lang="en-GB" sz="4400" dirty="0">
+            <a:br>
+              <a:rPr lang="en-GB" sz="3200" dirty="0">
+                <a:solidFill>
+                  <a:schemeClr val="bg1"/>
+                </a:solidFill>
+              </a:rPr>
+            </a:br>
+            <a:r>
+              <a:rPr lang="en-GB" sz="3200" dirty="0">
                 <a:solidFill>
                   <a:schemeClr val="bg1"/>
                 </a:solidFill>
@@ -4857,7 +4864,7 @@
               <a:t>Finally check that you’ve included </a:t>
             </a:r>
             <a:r>
-              <a:rPr lang="en-GB" sz="4400" b="1" dirty="0">
+              <a:rPr lang="en-GB" sz="3200" b="1" dirty="0">
                 <a:solidFill>
                   <a:schemeClr val="bg1"/>
                 </a:solidFill>
@@ -4865,7 +4872,7 @@
               <a:t>all</a:t>
             </a:r>
             <a:r>
-              <a:rPr lang="en-GB" sz="4400" dirty="0">
+              <a:rPr lang="en-GB" sz="3200" dirty="0">
                 <a:solidFill>
                   <a:schemeClr val="bg1"/>
                 </a:solidFill>
@@ -4886,8 +4893,15 @@
                 </a:solidFill>
               </a:rPr>
             </a:br>
-            <a:r>
-              <a:rPr lang="en-GB" sz="4000" dirty="0">
+            <a:br>
+              <a:rPr lang="en-GB" sz="3600" dirty="0">
+                <a:solidFill>
+                  <a:schemeClr val="bg1"/>
+                </a:solidFill>
+              </a:rPr>
+            </a:br>
+            <a:r>
+              <a:rPr lang="en-GB" sz="3600" dirty="0">
                 <a:solidFill>
                   <a:schemeClr val="bg1"/>
                 </a:solidFill>

</xml_diff>